<commit_message>
chore : nettoyage du projet — suppression des fichiers inutiles
- Supprime les scripts exploratoires (00_inspect*.py, 01_exploration.py, _run_vif_only.py)
- Supprime generate_report.py (rapport déjà généré), generate_presentation_v2.py (doublon)
- Supprime METHODOLOGIE_SCIENTIFIQUE.md, column_names.txt, variable_labels.txt
- Supprime catboost_info/ (logs d'entraînement), best_ml_pipeline.pkl (ancien artifact)
- Supprime __pycache__, fichiers temporaires Office (~$*, ~WRL*)
- Supprime archives et anciens PDF intermédiaires
- Ajoute abstract_mortalite_infantile.docx/.pdf, Presentation_MI_Cameroun_ML.pptx
- Renomme le rapport final avec le nom auteur

Co-Authored-By: Claude Sonnet 4.6 <noreply@anthropic.com>
</commit_message>
<xml_diff>
--- a/Presentation_Mortalite_Infantile_Cameroun.pptx
+++ b/Presentation_Mortalite_Infantile_Cameroun.pptx
@@ -320,7 +320,7 @@
           <a:p>
             <a:fld id="{5BCAD085-E8A6-8845-BD4E-CB4CCA059FC4}" type="datetimeFigureOut">
               <a:rPr lang="en-US" smtClean="0"/>
-              <a:t>6/24/2026</a:t>
+              <a:t>7/17/2026</a:t>
             </a:fld>
             <a:endParaRPr lang="en-US"/>
           </a:p>
@@ -488,7 +488,7 @@
           <a:p>
             <a:fld id="{5BCAD085-E8A6-8845-BD4E-CB4CCA059FC4}" type="datetimeFigureOut">
               <a:rPr lang="en-US" smtClean="0"/>
-              <a:t>6/24/2026</a:t>
+              <a:t>7/17/2026</a:t>
             </a:fld>
             <a:endParaRPr lang="en-US"/>
           </a:p>
@@ -666,7 +666,7 @@
           <a:p>
             <a:fld id="{5BCAD085-E8A6-8845-BD4E-CB4CCA059FC4}" type="datetimeFigureOut">
               <a:rPr lang="en-US" smtClean="0"/>
-              <a:t>6/24/2026</a:t>
+              <a:t>7/17/2026</a:t>
             </a:fld>
             <a:endParaRPr lang="en-US"/>
           </a:p>
@@ -834,7 +834,7 @@
           <a:p>
             <a:fld id="{5BCAD085-E8A6-8845-BD4E-CB4CCA059FC4}" type="datetimeFigureOut">
               <a:rPr lang="en-US" smtClean="0"/>
-              <a:t>6/24/2026</a:t>
+              <a:t>7/17/2026</a:t>
             </a:fld>
             <a:endParaRPr lang="en-US"/>
           </a:p>
@@ -1079,7 +1079,7 @@
           <a:p>
             <a:fld id="{5BCAD085-E8A6-8845-BD4E-CB4CCA059FC4}" type="datetimeFigureOut">
               <a:rPr lang="en-US" smtClean="0"/>
-              <a:t>6/24/2026</a:t>
+              <a:t>7/17/2026</a:t>
             </a:fld>
             <a:endParaRPr lang="en-US"/>
           </a:p>
@@ -1364,7 +1364,7 @@
           <a:p>
             <a:fld id="{5BCAD085-E8A6-8845-BD4E-CB4CCA059FC4}" type="datetimeFigureOut">
               <a:rPr lang="en-US" smtClean="0"/>
-              <a:t>6/24/2026</a:t>
+              <a:t>7/17/2026</a:t>
             </a:fld>
             <a:endParaRPr lang="en-US"/>
           </a:p>
@@ -1783,7 +1783,7 @@
           <a:p>
             <a:fld id="{5BCAD085-E8A6-8845-BD4E-CB4CCA059FC4}" type="datetimeFigureOut">
               <a:rPr lang="en-US" smtClean="0"/>
-              <a:t>6/24/2026</a:t>
+              <a:t>7/17/2026</a:t>
             </a:fld>
             <a:endParaRPr lang="en-US"/>
           </a:p>
@@ -1900,7 +1900,7 @@
           <a:p>
             <a:fld id="{5BCAD085-E8A6-8845-BD4E-CB4CCA059FC4}" type="datetimeFigureOut">
               <a:rPr lang="en-US" smtClean="0"/>
-              <a:t>6/24/2026</a:t>
+              <a:t>7/17/2026</a:t>
             </a:fld>
             <a:endParaRPr lang="en-US"/>
           </a:p>
@@ -1995,7 +1995,7 @@
           <a:p>
             <a:fld id="{5BCAD085-E8A6-8845-BD4E-CB4CCA059FC4}" type="datetimeFigureOut">
               <a:rPr lang="en-US" smtClean="0"/>
-              <a:t>6/24/2026</a:t>
+              <a:t>7/17/2026</a:t>
             </a:fld>
             <a:endParaRPr lang="en-US"/>
           </a:p>
@@ -2270,7 +2270,7 @@
           <a:p>
             <a:fld id="{5BCAD085-E8A6-8845-BD4E-CB4CCA059FC4}" type="datetimeFigureOut">
               <a:rPr lang="en-US" smtClean="0"/>
-              <a:t>6/24/2026</a:t>
+              <a:t>7/17/2026</a:t>
             </a:fld>
             <a:endParaRPr lang="en-US"/>
           </a:p>
@@ -2522,7 +2522,7 @@
           <a:p>
             <a:fld id="{5BCAD085-E8A6-8845-BD4E-CB4CCA059FC4}" type="datetimeFigureOut">
               <a:rPr lang="en-US" smtClean="0"/>
-              <a:t>6/24/2026</a:t>
+              <a:t>7/17/2026</a:t>
             </a:fld>
             <a:endParaRPr lang="en-US"/>
           </a:p>
@@ -2733,7 +2733,7 @@
           <a:p>
             <a:fld id="{5BCAD085-E8A6-8845-BD4E-CB4CCA059FC4}" type="datetimeFigureOut">
               <a:rPr lang="en-US" smtClean="0"/>
-              <a:t>6/24/2026</a:t>
+              <a:t>7/17/2026</a:t>
             </a:fld>
             <a:endParaRPr lang="en-US"/>
           </a:p>

</xml_diff>